<commit_message>
Video live + deck links filled (repo URL + 62s demo capture)
</commit_message>
<xml_diff>
--- a/docs/DrishtiNet_KLA_PS01_final.pptx
+++ b/docs/DrishtiNet_KLA_PS01_final.pptx
@@ -15350,7 +15350,7 @@
                 </a:solidFill>
                 <a:latin typeface="Segoe UI"/>
               </a:rPr>
-              <a:t>GitHub:  [ FILL — repo goes public at submission ]</a:t>
+              <a:t>GitHub:  github.com/Adityag476/DRISHTI-Net (public — code, weights, outputs, reports)</a:t>
             </a:r>
           </a:p>
           <a:p>
@@ -15369,7 +15369,7 @@
                 </a:solidFill>
                 <a:latin typeface="Segoe UI"/>
               </a:rPr>
-              <a:t>Video:  [ FILL — 90-second capture: fresh clone → evaluate.py restoring a folder ]</a:t>
+              <a:t>Video:  youtu.be/XoaiKg5po4c — 62-second capture: evaluate.py live restore + measured reports</a:t>
             </a:r>
           </a:p>
           <a:p>

</xml_diff>